<commit_message>
docs: regenerate bilingual manual deck
</commit_message>
<xml_diff>
--- a/app/static/user_manual_bilingual.pptx
+++ b/app/static/user_manual_bilingual.pptx
@@ -3212,32 +3212,37 @@
                 <a:solidFill>
                   <a:srgbClr val="12211C"/>
                 </a:solidFill>
+                <a:latin typeface="Aptos"/>
               </a:rPr>
               <a:t>Missing Person Nepal</a:t>
             </a:r>
           </a:p>
           <a:p>
-            <a:pPr>
-              <a:defRPr sz="2000" b="1">
+            <a:r>
+              <a:t>User Manual and Operational Training Guide</a:t>
+            </a:r>
+            <a:r>
+              <a:rPr sz="2000" b="1">
                 <a:solidFill>
                   <a:srgbClr val="2F553B"/>
                 </a:solidFill>
-              </a:defRPr>
-            </a:pPr>
-            <a:r>
-              <a:t>User Manual and Operational Training Guide</a:t>
-            </a:r>
-          </a:p>
-          <a:p>
-            <a:pPr>
-              <a:defRPr sz="1400">
+                <a:latin typeface="Aptos"/>
+              </a:rPr>
+              <a:t/>
+            </a:r>
+          </a:p>
+          <a:p>
+            <a:r>
+              <a:t>Bilingual English and Nepali presentation for admins, coordinators, and handover briefings.</a:t>
+            </a:r>
+            <a:r>
+              <a:rPr sz="1400" b="0">
                 <a:solidFill>
                   <a:srgbClr val="66706C"/>
                 </a:solidFill>
-              </a:defRPr>
-            </a:pPr>
-            <a:r>
-              <a:t>Bilingual English and Nepali presentation for admins, coordinators, and handover briefings.</a:t>
+                <a:latin typeface="Aptos"/>
+              </a:rPr>
+              <a:t/>
             </a:r>
           </a:p>
         </p:txBody>
@@ -3377,19 +3382,19 @@
                 <a:solidFill>
                   <a:srgbClr val="12211C"/>
                 </a:solidFill>
+                <a:latin typeface="Aptos"/>
               </a:rPr>
               <a:t>Purpose of the System</a:t>
             </a:r>
           </a:p>
           <a:p>
-            <a:pPr>
-              <a:defRPr sz="1200">
+            <a:r>
+              <a:rPr sz="1200" b="0">
                 <a:solidFill>
                   <a:srgbClr val="66706C"/>
                 </a:solidFill>
-              </a:defRPr>
-            </a:pPr>
-            <a:r>
+                <a:latin typeface="Aptos"/>
+              </a:rPr>
               <a:t>What it is for</a:t>
             </a:r>
           </a:p>
@@ -3457,16 +3462,17 @@
           <a:noFill/>
         </p:spPr>
         <p:txBody>
-          <a:bodyPr wrap="none">
+          <a:bodyPr wrap="square">
             <a:spAutoFit/>
           </a:bodyPr>
           <a:lstStyle/>
           <a:p>
             <a:r>
-              <a:rPr b="1" sz="1600">
+              <a:rPr sz="1600" b="1">
                 <a:solidFill>
                   <a:srgbClr val="2F553B"/>
                 </a:solidFill>
+                <a:latin typeface="Aptos"/>
               </a:rPr>
               <a:t>English</a:t>
             </a:r>
@@ -3476,13 +3482,14 @@
               <a:spcAft>
                 <a:spcPts val="400"/>
               </a:spcAft>
-              <a:defRPr sz="1300">
+            </a:pPr>
+            <a:r>
+              <a:rPr sz="1300" b="0">
                 <a:solidFill>
                   <a:srgbClr val="12211C"/>
                 </a:solidFill>
-              </a:defRPr>
-            </a:pPr>
-            <a:r>
+                <a:latin typeface="Aptos"/>
+              </a:rPr>
               <a:t>Collects public reports and direct submissions for disaster-related missing persons.</a:t>
             </a:r>
           </a:p>
@@ -3491,13 +3498,14 @@
               <a:spcAft>
                 <a:spcPts val="400"/>
               </a:spcAft>
-              <a:defRPr sz="1300">
+            </a:pPr>
+            <a:r>
+              <a:rPr sz="1300" b="0">
                 <a:solidFill>
                   <a:srgbClr val="12211C"/>
                 </a:solidFill>
-              </a:defRPr>
-            </a:pPr>
-            <a:r>
+                <a:latin typeface="Aptos"/>
+              </a:rPr>
               <a:t>Keeps source links, notes, and evidence attached to the right person record.</a:t>
             </a:r>
           </a:p>
@@ -3506,13 +3514,14 @@
               <a:spcAft>
                 <a:spcPts val="400"/>
               </a:spcAft>
-              <a:defRPr sz="1300">
+            </a:pPr>
+            <a:r>
+              <a:rPr sz="1300" b="0">
                 <a:solidFill>
                   <a:srgbClr val="12211C"/>
                 </a:solidFill>
-              </a:defRPr>
-            </a:pPr>
-            <a:r>
+                <a:latin typeface="Aptos"/>
+              </a:rPr>
               <a:t>Helps admins spot likely duplicates before publishing or merging cases.</a:t>
             </a:r>
           </a:p>
@@ -3521,13 +3530,14 @@
               <a:spcAft>
                 <a:spcPts val="400"/>
               </a:spcAft>
-              <a:defRPr sz="1300">
+            </a:pPr>
+            <a:r>
+              <a:rPr sz="1300" b="0">
                 <a:solidFill>
                   <a:srgbClr val="12211C"/>
                 </a:solidFill>
-              </a:defRPr>
-            </a:pPr>
-            <a:r>
+                <a:latin typeface="Aptos"/>
+              </a:rPr>
               <a:t>Supports search, review, publishing, export, and shift handover in one place.</a:t>
             </a:r>
           </a:p>
@@ -3595,16 +3605,17 @@
           <a:noFill/>
         </p:spPr>
         <p:txBody>
-          <a:bodyPr wrap="none">
+          <a:bodyPr wrap="square">
             <a:spAutoFit/>
           </a:bodyPr>
           <a:lstStyle/>
           <a:p>
             <a:r>
-              <a:rPr b="1" sz="1600">
+              <a:rPr sz="1600" b="1">
                 <a:solidFill>
                   <a:srgbClr val="2F553B"/>
                 </a:solidFill>
+                <a:latin typeface="Mangal"/>
               </a:rPr>
               <a:t>??????</a:t>
             </a:r>
@@ -3614,13 +3625,14 @@
               <a:spcAft>
                 <a:spcPts val="400"/>
               </a:spcAft>
-              <a:defRPr sz="1300">
+            </a:pPr>
+            <a:r>
+              <a:rPr sz="1300" b="0">
                 <a:solidFill>
                   <a:srgbClr val="12211C"/>
                 </a:solidFill>
-              </a:defRPr>
-            </a:pPr>
-            <a:r>
+                <a:latin typeface="Mangal"/>
+              </a:rPr>
               <a:t>???????? ????????? ??????? ????????? ????????? ??????? ? ????????? ????????? ????? ?????</a:t>
             </a:r>
           </a:p>
@@ -3629,13 +3641,14 @@
               <a:spcAft>
                 <a:spcPts val="400"/>
               </a:spcAft>
-              <a:defRPr sz="1300">
+            </a:pPr>
+            <a:r>
+              <a:rPr sz="1300" b="0">
                 <a:solidFill>
                   <a:srgbClr val="12211C"/>
                 </a:solidFill>
-              </a:defRPr>
-            </a:pPr>
-            <a:r>
+                <a:latin typeface="Mangal"/>
+              </a:rPr>
               <a:t>????? ????, ???, ? ?????? ??? ????????? ????????? ???????? ??????</a:t>
             </a:r>
           </a:p>
@@ -3644,13 +3657,14 @@
               <a:spcAft>
                 <a:spcPts val="400"/>
               </a:spcAft>
-              <a:defRPr sz="1300">
+            </a:pPr>
+            <a:r>
+              <a:rPr sz="1300" b="0">
                 <a:solidFill>
                   <a:srgbClr val="12211C"/>
                 </a:solidFill>
-              </a:defRPr>
-            </a:pPr>
-            <a:r>
+                <a:latin typeface="Mangal"/>
+              </a:rPr>
               <a:t>??????? ?? ???? ????? ??? ???????? ?????? ?????? ????? ????? ????? ?????</a:t>
             </a:r>
           </a:p>
@@ -3659,13 +3673,14 @@
               <a:spcAft>
                 <a:spcPts val="400"/>
               </a:spcAft>
-              <a:defRPr sz="1300">
+            </a:pPr>
+            <a:r>
+              <a:rPr sz="1300" b="0">
                 <a:solidFill>
                   <a:srgbClr val="12211C"/>
                 </a:solidFill>
-              </a:defRPr>
-            </a:pPr>
-            <a:r>
+                <a:latin typeface="Mangal"/>
+              </a:rPr>
               <a:t>???, ???????, ???????, export, ? shift handover ???? ?????? ?????? ?????</a:t>
             </a:r>
           </a:p>
@@ -3806,19 +3821,19 @@
                 <a:solidFill>
                   <a:srgbClr val="12211C"/>
                 </a:solidFill>
+                <a:latin typeface="Aptos"/>
               </a:rPr>
               <a:t>How It Works</a:t>
             </a:r>
           </a:p>
           <a:p>
-            <a:pPr>
-              <a:defRPr sz="1200">
+            <a:r>
+              <a:rPr sz="1200" b="0">
                 <a:solidFill>
                   <a:srgbClr val="66706C"/>
                 </a:solidFill>
-              </a:defRPr>
-            </a:pPr>
-            <a:r>
+                <a:latin typeface="Aptos"/>
+              </a:rPr>
               <a:t>Workflow overview</a:t>
             </a:r>
           </a:p>
@@ -3886,16 +3901,17 @@
           <a:noFill/>
         </p:spPr>
         <p:txBody>
-          <a:bodyPr wrap="none">
+          <a:bodyPr wrap="square">
             <a:spAutoFit/>
           </a:bodyPr>
           <a:lstStyle/>
           <a:p>
             <a:r>
-              <a:rPr b="1" sz="1600">
+              <a:rPr sz="1600" b="1">
                 <a:solidFill>
                   <a:srgbClr val="2F553B"/>
                 </a:solidFill>
+                <a:latin typeface="Aptos"/>
               </a:rPr>
               <a:t>English</a:t>
             </a:r>
@@ -3905,13 +3921,14 @@
               <a:spcAft>
                 <a:spcPts val="400"/>
               </a:spcAft>
-              <a:defRPr sz="1300">
+            </a:pPr>
+            <a:r>
+              <a:rPr sz="1300" b="0">
                 <a:solidFill>
                   <a:srgbClr val="12211C"/>
                 </a:solidFill>
-              </a:defRPr>
-            </a:pPr>
-            <a:r>
+                <a:latin typeface="Aptos"/>
+              </a:rPr>
               <a:t>Public reports and submissions enter the system.</a:t>
             </a:r>
           </a:p>
@@ -3920,13 +3937,14 @@
               <a:spcAft>
                 <a:spcPts val="400"/>
               </a:spcAft>
-              <a:defRPr sz="1300">
+            </a:pPr>
+            <a:r>
+              <a:rPr sz="1300" b="0">
                 <a:solidFill>
                   <a:srgbClr val="12211C"/>
                 </a:solidFill>
-              </a:defRPr>
-            </a:pPr>
-            <a:r>
+                <a:latin typeface="Aptos"/>
+              </a:rPr>
               <a:t>Discovery and review find matching public sources.</a:t>
             </a:r>
           </a:p>
@@ -3935,13 +3953,14 @@
               <a:spcAft>
                 <a:spcPts val="400"/>
               </a:spcAft>
-              <a:defRPr sz="1300">
+            </a:pPr>
+            <a:r>
+              <a:rPr sz="1300" b="0">
                 <a:solidFill>
                   <a:srgbClr val="12211C"/>
                 </a:solidFill>
-              </a:defRPr>
-            </a:pPr>
-            <a:r>
+                <a:latin typeface="Aptos"/>
+              </a:rPr>
               <a:t>Admins verify details and attach evidence to the correct record.</a:t>
             </a:r>
           </a:p>
@@ -3950,13 +3969,14 @@
               <a:spcAft>
                 <a:spcPts val="400"/>
               </a:spcAft>
-              <a:defRPr sz="1300">
+            </a:pPr>
+            <a:r>
+              <a:rPr sz="1300" b="0">
                 <a:solidFill>
                   <a:srgbClr val="12211C"/>
                 </a:solidFill>
-              </a:defRPr>
-            </a:pPr>
-            <a:r>
+                <a:latin typeface="Aptos"/>
+              </a:rPr>
               <a:t>Published cases remain searchable and up to date.</a:t>
             </a:r>
           </a:p>
@@ -4024,16 +4044,17 @@
           <a:noFill/>
         </p:spPr>
         <p:txBody>
-          <a:bodyPr wrap="none">
+          <a:bodyPr wrap="square">
             <a:spAutoFit/>
           </a:bodyPr>
           <a:lstStyle/>
           <a:p>
             <a:r>
-              <a:rPr b="1" sz="1600">
+              <a:rPr sz="1600" b="1">
                 <a:solidFill>
                   <a:srgbClr val="2F553B"/>
                 </a:solidFill>
+                <a:latin typeface="Mangal"/>
               </a:rPr>
               <a:t>??????</a:t>
             </a:r>
@@ -4043,13 +4064,14 @@
               <a:spcAft>
                 <a:spcPts val="400"/>
               </a:spcAft>
-              <a:defRPr sz="1300">
+            </a:pPr>
+            <a:r>
+              <a:rPr sz="1300" b="0">
                 <a:solidFill>
                   <a:srgbClr val="12211C"/>
                 </a:solidFill>
-              </a:defRPr>
-            </a:pPr>
-            <a:r>
+                <a:latin typeface="Mangal"/>
+              </a:rPr>
               <a:t>????????? ??????? ? ?????? ????????? ?????? ???????</a:t>
             </a:r>
           </a:p>
@@ -4058,13 +4080,14 @@
               <a:spcAft>
                 <a:spcPts val="400"/>
               </a:spcAft>
-              <a:defRPr sz="1300">
+            </a:pPr>
+            <a:r>
+              <a:rPr sz="1300" b="0">
                 <a:solidFill>
                   <a:srgbClr val="12211C"/>
                 </a:solidFill>
-              </a:defRPr>
-            </a:pPr>
-            <a:r>
+                <a:latin typeface="Mangal"/>
+              </a:rPr>
               <a:t>Discovery ? review ?? ?????? ????????? ???????? ???? ????????</a:t>
             </a:r>
           </a:p>
@@ -4073,13 +4096,14 @@
               <a:spcAft>
                 <a:spcPts val="400"/>
               </a:spcAft>
-              <a:defRPr sz="1300">
+            </a:pPr>
+            <a:r>
+              <a:rPr sz="1300" b="0">
                 <a:solidFill>
                   <a:srgbClr val="12211C"/>
                 </a:solidFill>
-              </a:defRPr>
-            </a:pPr>
-            <a:r>
+                <a:latin typeface="Mangal"/>
+              </a:rPr>
               <a:t>Admin ?? ????? ?????? ??? ????????? ?????? ????????</a:t>
             </a:r>
           </a:p>
@@ -4088,13 +4112,14 @@
               <a:spcAft>
                 <a:spcPts val="400"/>
               </a:spcAft>
-              <a:defRPr sz="1300">
+            </a:pPr>
+            <a:r>
+              <a:rPr sz="1300" b="0">
                 <a:solidFill>
                   <a:srgbClr val="12211C"/>
                 </a:solidFill>
-              </a:defRPr>
-            </a:pPr>
-            <a:r>
+                <a:latin typeface="Mangal"/>
+              </a:rPr>
               <a:t>???????? case ??? ????? ?????? ? ????????? ????????</a:t>
             </a:r>
           </a:p>
@@ -4235,19 +4260,19 @@
                 <a:solidFill>
                   <a:srgbClr val="12211C"/>
                 </a:solidFill>
+                <a:latin typeface="Aptos"/>
               </a:rPr>
               <a:t>How to Use the Admin Panel</a:t>
             </a:r>
           </a:p>
           <a:p>
-            <a:pPr>
-              <a:defRPr sz="1200">
+            <a:r>
+              <a:rPr sz="1200" b="0">
                 <a:solidFill>
                   <a:srgbClr val="66706C"/>
                 </a:solidFill>
-              </a:defRPr>
-            </a:pPr>
-            <a:r>
+                <a:latin typeface="Aptos"/>
+              </a:rPr>
               <a:t>Daily use</a:t>
             </a:r>
           </a:p>
@@ -4315,16 +4340,17 @@
           <a:noFill/>
         </p:spPr>
         <p:txBody>
-          <a:bodyPr wrap="none">
+          <a:bodyPr wrap="square">
             <a:spAutoFit/>
           </a:bodyPr>
           <a:lstStyle/>
           <a:p>
             <a:r>
-              <a:rPr b="1" sz="1600">
+              <a:rPr sz="1600" b="1">
                 <a:solidFill>
                   <a:srgbClr val="2F553B"/>
                 </a:solidFill>
+                <a:latin typeface="Aptos"/>
               </a:rPr>
               <a:t>English</a:t>
             </a:r>
@@ -4334,13 +4360,14 @@
               <a:spcAft>
                 <a:spcPts val="400"/>
               </a:spcAft>
-              <a:defRPr sz="1300">
+            </a:pPr>
+            <a:r>
+              <a:rPr sz="1300" b="0">
                 <a:solidFill>
                   <a:srgbClr val="12211C"/>
                 </a:solidFill>
-              </a:defRPr>
-            </a:pPr>
-            <a:r>
+                <a:latin typeface="Aptos"/>
+              </a:rPr>
               <a:t>Log in and open the Dashboard.</a:t>
             </a:r>
           </a:p>
@@ -4349,13 +4376,14 @@
               <a:spcAft>
                 <a:spcPts val="400"/>
               </a:spcAft>
-              <a:defRPr sz="1300">
+            </a:pPr>
+            <a:r>
+              <a:rPr sz="1300" b="0">
                 <a:solidFill>
                   <a:srgbClr val="12211C"/>
                 </a:solidFill>
-              </a:defRPr>
-            </a:pPr>
-            <a:r>
+                <a:latin typeface="Aptos"/>
+              </a:rPr>
               <a:t>Use Discovery to review source candidates.</a:t>
             </a:r>
           </a:p>
@@ -4364,13 +4392,14 @@
               <a:spcAft>
                 <a:spcPts val="400"/>
               </a:spcAft>
-              <a:defRPr sz="1300">
+            </a:pPr>
+            <a:r>
+              <a:rPr sz="1300" b="0">
                 <a:solidFill>
                   <a:srgbClr val="12211C"/>
                 </a:solidFill>
-              </a:defRPr>
-            </a:pPr>
-            <a:r>
+                <a:latin typeface="Aptos"/>
+              </a:rPr>
               <a:t>Approve submissions or attach them to existing people.</a:t>
             </a:r>
           </a:p>
@@ -4379,13 +4408,14 @@
               <a:spcAft>
                 <a:spcPts val="400"/>
               </a:spcAft>
-              <a:defRPr sz="1300">
+            </a:pPr>
+            <a:r>
+              <a:rPr sz="1300" b="0">
                 <a:solidFill>
                   <a:srgbClr val="12211C"/>
                 </a:solidFill>
-              </a:defRPr>
-            </a:pPr>
-            <a:r>
+                <a:latin typeface="Aptos"/>
+              </a:rPr>
               <a:t>Open People and Events to maintain case records.</a:t>
             </a:r>
           </a:p>
@@ -4394,13 +4424,14 @@
               <a:spcAft>
                 <a:spcPts val="400"/>
               </a:spcAft>
-              <a:defRPr sz="1300">
+            </a:pPr>
+            <a:r>
+              <a:rPr sz="1300" b="0">
                 <a:solidFill>
                   <a:srgbClr val="12211C"/>
                 </a:solidFill>
-              </a:defRPr>
-            </a:pPr>
-            <a:r>
+                <a:latin typeface="Aptos"/>
+              </a:rPr>
               <a:t>Use Export and Help &amp; Training for handover.</a:t>
             </a:r>
           </a:p>
@@ -4468,16 +4499,17 @@
           <a:noFill/>
         </p:spPr>
         <p:txBody>
-          <a:bodyPr wrap="none">
+          <a:bodyPr wrap="square">
             <a:spAutoFit/>
           </a:bodyPr>
           <a:lstStyle/>
           <a:p>
             <a:r>
-              <a:rPr b="1" sz="1600">
+              <a:rPr sz="1600" b="1">
                 <a:solidFill>
                   <a:srgbClr val="2F553B"/>
                 </a:solidFill>
+                <a:latin typeface="Mangal"/>
               </a:rPr>
               <a:t>??????</a:t>
             </a:r>
@@ -4487,13 +4519,14 @@
               <a:spcAft>
                 <a:spcPts val="400"/>
               </a:spcAft>
-              <a:defRPr sz="1300">
+            </a:pPr>
+            <a:r>
+              <a:rPr sz="1300" b="0">
                 <a:solidFill>
                   <a:srgbClr val="12211C"/>
                 </a:solidFill>
-              </a:defRPr>
-            </a:pPr>
-            <a:r>
+                <a:latin typeface="Mangal"/>
+              </a:rPr>
               <a:t>????? ???? Dashboard ???????????</a:t>
             </a:r>
           </a:p>
@@ -4502,13 +4535,14 @@
               <a:spcAft>
                 <a:spcPts val="400"/>
               </a:spcAft>
-              <a:defRPr sz="1300">
+            </a:pPr>
+            <a:r>
+              <a:rPr sz="1300" b="0">
                 <a:solidFill>
                   <a:srgbClr val="12211C"/>
                 </a:solidFill>
-              </a:defRPr>
-            </a:pPr>
-            <a:r>
+                <a:latin typeface="Mangal"/>
+              </a:rPr>
               <a:t>Discovery ?????? ???? candidate ???????? ??????? ??????????</a:t>
             </a:r>
           </a:p>
@@ -4517,13 +4551,14 @@
               <a:spcAft>
                 <a:spcPts val="400"/>
               </a:spcAft>
-              <a:defRPr sz="1300">
+            </a:pPr>
+            <a:r>
+              <a:rPr sz="1300" b="0">
                 <a:solidFill>
                   <a:srgbClr val="12211C"/>
                 </a:solidFill>
-              </a:defRPr>
-            </a:pPr>
-            <a:r>
+                <a:latin typeface="Mangal"/>
+              </a:rPr>
               <a:t>Submissions approve ????????? ?? existing ?????????? ???????????</a:t>
             </a:r>
           </a:p>
@@ -4532,13 +4567,14 @@
               <a:spcAft>
                 <a:spcPts val="400"/>
               </a:spcAft>
-              <a:defRPr sz="1300">
+            </a:pPr>
+            <a:r>
+              <a:rPr sz="1300" b="0">
                 <a:solidFill>
                   <a:srgbClr val="12211C"/>
                 </a:solidFill>
-              </a:defRPr>
-            </a:pPr>
-            <a:r>
+                <a:latin typeface="Mangal"/>
+              </a:rPr>
               <a:t>People ? Events ?? ??? case ????????? ??????????</a:t>
             </a:r>
           </a:p>
@@ -4547,13 +4583,14 @@
               <a:spcAft>
                 <a:spcPts val="400"/>
               </a:spcAft>
-              <a:defRPr sz="1300">
+            </a:pPr>
+            <a:r>
+              <a:rPr sz="1300" b="0">
                 <a:solidFill>
                   <a:srgbClr val="12211C"/>
                 </a:solidFill>
-              </a:defRPr>
-            </a:pPr>
-            <a:r>
+                <a:latin typeface="Mangal"/>
+              </a:rPr>
               <a:t>Export ? Help &amp; Training ??? handover ??????????</a:t>
             </a:r>
           </a:p>
@@ -4694,19 +4731,19 @@
                 <a:solidFill>
                   <a:srgbClr val="12211C"/>
                 </a:solidFill>
+                <a:latin typeface="Aptos"/>
               </a:rPr>
               <a:t>Map Features</a:t>
             </a:r>
           </a:p>
           <a:p>
-            <a:pPr>
-              <a:defRPr sz="1200">
+            <a:r>
+              <a:rPr sz="1200" b="0">
                 <a:solidFill>
                   <a:srgbClr val="66706C"/>
                 </a:solidFill>
-              </a:defRPr>
-            </a:pPr>
-            <a:r>
+                <a:latin typeface="Aptos"/>
+              </a:rPr>
               <a:t>Operational map tools</a:t>
             </a:r>
           </a:p>
@@ -4774,16 +4811,17 @@
           <a:noFill/>
         </p:spPr>
         <p:txBody>
-          <a:bodyPr wrap="none">
+          <a:bodyPr wrap="square">
             <a:spAutoFit/>
           </a:bodyPr>
           <a:lstStyle/>
           <a:p>
             <a:r>
-              <a:rPr b="1" sz="1600">
+              <a:rPr sz="1600" b="1">
                 <a:solidFill>
                   <a:srgbClr val="2F553B"/>
                 </a:solidFill>
+                <a:latin typeface="Aptos"/>
               </a:rPr>
               <a:t>English</a:t>
             </a:r>
@@ -4793,13 +4831,14 @@
               <a:spcAft>
                 <a:spcPts val="400"/>
               </a:spcAft>
-              <a:defRPr sz="1300">
+            </a:pPr>
+            <a:r>
+              <a:rPr sz="1300" b="0">
                 <a:solidFill>
                   <a:srgbClr val="12211C"/>
                 </a:solidFill>
-              </a:defRPr>
-            </a:pPr>
-            <a:r>
+                <a:latin typeface="Aptos"/>
+              </a:rPr>
               <a:t>Cluster pins to reduce clutter.</a:t>
             </a:r>
           </a:p>
@@ -4808,13 +4847,14 @@
               <a:spcAft>
                 <a:spcPts val="400"/>
               </a:spcAft>
-              <a:defRPr sz="1300">
+            </a:pPr>
+            <a:r>
+              <a:rPr sz="1300" b="0">
                 <a:solidFill>
                   <a:srgbClr val="12211C"/>
                 </a:solidFill>
-              </a:defRPr>
-            </a:pPr>
-            <a:r>
+                <a:latin typeface="Aptos"/>
+              </a:rPr>
               <a:t>Heatmap to show hotspots.</a:t>
             </a:r>
           </a:p>
@@ -4823,13 +4863,14 @@
               <a:spcAft>
                 <a:spcPts val="400"/>
               </a:spcAft>
-              <a:defRPr sz="1300">
+            </a:pPr>
+            <a:r>
+              <a:rPr sz="1300" b="0">
                 <a:solidFill>
                   <a:srgbClr val="12211C"/>
                 </a:solidFill>
-              </a:defRPr>
-            </a:pPr>
-            <a:r>
+                <a:latin typeface="Aptos"/>
+              </a:rPr>
               <a:t>Circle or boundary overlays for event areas.</a:t>
             </a:r>
           </a:p>
@@ -4838,13 +4879,14 @@
               <a:spcAft>
                 <a:spcPts val="400"/>
               </a:spcAft>
-              <a:defRPr sz="1300">
+            </a:pPr>
+            <a:r>
+              <a:rPr sz="1300" b="0">
                 <a:solidFill>
                   <a:srgbClr val="12211C"/>
                 </a:solidFill>
-              </a:defRPr>
-            </a:pPr>
-            <a:r>
+                <a:latin typeface="Aptos"/>
+              </a:rPr>
               <a:t>Nearby-case search and route overlays for coordination.</a:t>
             </a:r>
           </a:p>
@@ -4912,16 +4954,17 @@
           <a:noFill/>
         </p:spPr>
         <p:txBody>
-          <a:bodyPr wrap="none">
+          <a:bodyPr wrap="square">
             <a:spAutoFit/>
           </a:bodyPr>
           <a:lstStyle/>
           <a:p>
             <a:r>
-              <a:rPr b="1" sz="1600">
+              <a:rPr sz="1600" b="1">
                 <a:solidFill>
                   <a:srgbClr val="2F553B"/>
                 </a:solidFill>
+                <a:latin typeface="Mangal"/>
               </a:rPr>
               <a:t>??????</a:t>
             </a:r>
@@ -4931,13 +4974,14 @@
               <a:spcAft>
                 <a:spcPts val="400"/>
               </a:spcAft>
-              <a:defRPr sz="1300">
+            </a:pPr>
+            <a:r>
+              <a:rPr sz="1300" b="0">
                 <a:solidFill>
                   <a:srgbClr val="12211C"/>
                 </a:solidFill>
-              </a:defRPr>
-            </a:pPr>
-            <a:r>
+                <a:latin typeface="Mangal"/>
+              </a:rPr>
               <a:t>??? ?? ???? cluster pins ?????? ??????</a:t>
             </a:r>
           </a:p>
@@ -4946,13 +4990,14 @@
               <a:spcAft>
                 <a:spcPts val="400"/>
               </a:spcAft>
-              <a:defRPr sz="1300">
+            </a:pPr>
+            <a:r>
+              <a:rPr sz="1300" b="0">
                 <a:solidFill>
                   <a:srgbClr val="12211C"/>
                 </a:solidFill>
-              </a:defRPr>
-            </a:pPr>
-            <a:r>
+                <a:latin typeface="Mangal"/>
+              </a:rPr>
               <a:t>Hotspot ?????? heatmap ?????? ??</a:t>
             </a:r>
           </a:p>
@@ -4961,13 +5006,14 @@
               <a:spcAft>
                 <a:spcPts val="400"/>
               </a:spcAft>
-              <a:defRPr sz="1300">
+            </a:pPr>
+            <a:r>
+              <a:rPr sz="1300" b="0">
                 <a:solidFill>
                   <a:srgbClr val="12211C"/>
                 </a:solidFill>
-              </a:defRPr>
-            </a:pPr>
-            <a:r>
+                <a:latin typeface="Mangal"/>
+              </a:rPr>
               <a:t>???? ??????? ?????? circle ?? boundary overlay ?????? ??????</a:t>
             </a:r>
           </a:p>
@@ -4976,13 +5022,14 @@
               <a:spcAft>
                 <a:spcPts val="400"/>
               </a:spcAft>
-              <a:defRPr sz="1300">
+            </a:pPr>
+            <a:r>
+              <a:rPr sz="1300" b="0">
                 <a:solidFill>
                   <a:srgbClr val="12211C"/>
                 </a:solidFill>
-              </a:defRPr>
-            </a:pPr>
-            <a:r>
+                <a:latin typeface="Mangal"/>
+              </a:rPr>
               <a:t>?????? case ? route overlay ???????? ???? ?????? ????</a:t>
             </a:r>
           </a:p>
@@ -5123,19 +5170,19 @@
                 <a:solidFill>
                   <a:srgbClr val="12211C"/>
                 </a:solidFill>
+                <a:latin typeface="Aptos"/>
               </a:rPr>
               <a:t>Search and Discovery</a:t>
             </a:r>
           </a:p>
           <a:p>
-            <a:pPr>
-              <a:defRPr sz="1200">
+            <a:r>
+              <a:rPr sz="1200" b="0">
                 <a:solidFill>
                   <a:srgbClr val="66706C"/>
                 </a:solidFill>
-              </a:defRPr>
-            </a:pPr>
-            <a:r>
+                <a:latin typeface="Aptos"/>
+              </a:rPr>
               <a:t>Google-backed wide search</a:t>
             </a:r>
           </a:p>
@@ -5203,16 +5250,17 @@
           <a:noFill/>
         </p:spPr>
         <p:txBody>
-          <a:bodyPr wrap="none">
+          <a:bodyPr wrap="square">
             <a:spAutoFit/>
           </a:bodyPr>
           <a:lstStyle/>
           <a:p>
             <a:r>
-              <a:rPr b="1" sz="1600">
+              <a:rPr sz="1600" b="1">
                 <a:solidFill>
                   <a:srgbClr val="2F553B"/>
                 </a:solidFill>
+                <a:latin typeface="Aptos"/>
               </a:rPr>
               <a:t>English</a:t>
             </a:r>
@@ -5222,13 +5270,14 @@
               <a:spcAft>
                 <a:spcPts val="400"/>
               </a:spcAft>
-              <a:defRPr sz="1300">
+            </a:pPr>
+            <a:r>
+              <a:rPr sz="1300" b="0">
                 <a:solidFill>
                   <a:srgbClr val="12211C"/>
                 </a:solidFill>
-              </a:defRPr>
-            </a:pPr>
-            <a:r>
+                <a:latin typeface="Aptos"/>
+              </a:rPr>
               <a:t>Wide search uses Google-backed discovery when configured.</a:t>
             </a:r>
           </a:p>
@@ -5237,13 +5286,14 @@
               <a:spcAft>
                 <a:spcPts val="400"/>
               </a:spcAft>
-              <a:defRPr sz="1300">
+            </a:pPr>
+            <a:r>
+              <a:rPr sz="1300" b="0">
                 <a:solidFill>
                   <a:srgbClr val="12211C"/>
                 </a:solidFill>
-              </a:defRPr>
-            </a:pPr>
-            <a:r>
+                <a:latin typeface="Aptos"/>
+              </a:rPr>
               <a:t>Operator-added search tags improve coverage.</a:t>
             </a:r>
           </a:p>
@@ -5252,13 +5302,14 @@
               <a:spcAft>
                 <a:spcPts val="400"/>
               </a:spcAft>
-              <a:defRPr sz="1300">
+            </a:pPr>
+            <a:r>
+              <a:rPr sz="1300" b="0">
                 <a:solidFill>
                   <a:srgbClr val="12211C"/>
                 </a:solidFill>
-              </a:defRPr>
-            </a:pPr>
-            <a:r>
+                <a:latin typeface="Aptos"/>
+              </a:rPr>
               <a:t>Manual fallback links stay visible even if the provider key is missing.</a:t>
             </a:r>
           </a:p>
@@ -5267,13 +5318,14 @@
               <a:spcAft>
                 <a:spcPts val="400"/>
               </a:spcAft>
-              <a:defRPr sz="1300">
+            </a:pPr>
+            <a:r>
+              <a:rPr sz="1300" b="0">
                 <a:solidFill>
                   <a:srgbClr val="12211C"/>
                 </a:solidFill>
-              </a:defRPr>
-            </a:pPr>
-            <a:r>
+                <a:latin typeface="Aptos"/>
+              </a:rPr>
               <a:t>Search results still require human review before publishing.</a:t>
             </a:r>
           </a:p>
@@ -5341,16 +5393,17 @@
           <a:noFill/>
         </p:spPr>
         <p:txBody>
-          <a:bodyPr wrap="none">
+          <a:bodyPr wrap="square">
             <a:spAutoFit/>
           </a:bodyPr>
           <a:lstStyle/>
           <a:p>
             <a:r>
-              <a:rPr b="1" sz="1600">
+              <a:rPr sz="1600" b="1">
                 <a:solidFill>
                   <a:srgbClr val="2F553B"/>
                 </a:solidFill>
+                <a:latin typeface="Mangal"/>
               </a:rPr>
               <a:t>??????</a:t>
             </a:r>
@@ -5360,13 +5413,14 @@
               <a:spcAft>
                 <a:spcPts val="400"/>
               </a:spcAft>
-              <a:defRPr sz="1300">
+            </a:pPr>
+            <a:r>
+              <a:rPr sz="1300" b="0">
                 <a:solidFill>
                   <a:srgbClr val="12211C"/>
                 </a:solidFill>
-              </a:defRPr>
-            </a:pPr>
-            <a:r>
+                <a:latin typeface="Mangal"/>
+              </a:rPr>
               <a:t>Wide search ??????? ???? Google-backed ??? ?????? ??????</a:t>
             </a:r>
           </a:p>
@@ -5375,13 +5429,14 @@
               <a:spcAft>
                 <a:spcPts val="400"/>
               </a:spcAft>
-              <a:defRPr sz="1300">
+            </a:pPr>
+            <a:r>
+              <a:rPr sz="1300" b="0">
                 <a:solidFill>
                   <a:srgbClr val="12211C"/>
                 </a:solidFill>
-              </a:defRPr>
-            </a:pPr>
-            <a:r>
+                <a:latin typeface="Mangal"/>
+              </a:rPr>
               <a:t>Operator ?? ????? search tag ?? coverage ?????????</a:t>
             </a:r>
           </a:p>
@@ -5390,13 +5445,14 @@
               <a:spcAft>
                 <a:spcPts val="400"/>
               </a:spcAft>
-              <a:defRPr sz="1300">
+            </a:pPr>
+            <a:r>
+              <a:rPr sz="1300" b="0">
                 <a:solidFill>
                   <a:srgbClr val="12211C"/>
                 </a:solidFill>
-              </a:defRPr>
-            </a:pPr>
-            <a:r>
+                <a:latin typeface="Mangal"/>
+              </a:rPr>
               <a:t>Provider key ??? ??? manual Google search links ??????????</a:t>
             </a:r>
           </a:p>
@@ -5405,13 +5461,14 @@
               <a:spcAft>
                 <a:spcPts val="400"/>
               </a:spcAft>
-              <a:defRPr sz="1300">
+            </a:pPr>
+            <a:r>
+              <a:rPr sz="1300" b="0">
                 <a:solidFill>
                   <a:srgbClr val="12211C"/>
                 </a:solidFill>
-              </a:defRPr>
-            </a:pPr>
-            <a:r>
+                <a:latin typeface="Mangal"/>
+              </a:rPr>
               <a:t>??????? ??? ??? result ?????? ??????? ?????</a:t>
             </a:r>
           </a:p>
@@ -5552,19 +5609,19 @@
                 <a:solidFill>
                   <a:srgbClr val="12211C"/>
                 </a:solidFill>
+                <a:latin typeface="Aptos"/>
               </a:rPr>
               <a:t>Safety and Quality</a:t>
             </a:r>
           </a:p>
           <a:p>
-            <a:pPr>
-              <a:defRPr sz="1200">
+            <a:r>
+              <a:rPr sz="1200" b="0">
                 <a:solidFill>
                   <a:srgbClr val="66706C"/>
                 </a:solidFill>
-              </a:defRPr>
-            </a:pPr>
-            <a:r>
+                <a:latin typeface="Aptos"/>
+              </a:rPr>
               <a:t>What admins must check</a:t>
             </a:r>
           </a:p>
@@ -5632,16 +5689,17 @@
           <a:noFill/>
         </p:spPr>
         <p:txBody>
-          <a:bodyPr wrap="none">
+          <a:bodyPr wrap="square">
             <a:spAutoFit/>
           </a:bodyPr>
           <a:lstStyle/>
           <a:p>
             <a:r>
-              <a:rPr b="1" sz="1600">
+              <a:rPr sz="1600" b="1">
                 <a:solidFill>
                   <a:srgbClr val="2F553B"/>
                 </a:solidFill>
+                <a:latin typeface="Aptos"/>
               </a:rPr>
               <a:t>English</a:t>
             </a:r>
@@ -5651,13 +5709,14 @@
               <a:spcAft>
                 <a:spcPts val="400"/>
               </a:spcAft>
-              <a:defRPr sz="1300">
+            </a:pPr>
+            <a:r>
+              <a:rPr sz="1300" b="0">
                 <a:solidFill>
                   <a:srgbClr val="12211C"/>
                 </a:solidFill>
-              </a:defRPr>
-            </a:pPr>
-            <a:r>
+                <a:latin typeface="Aptos"/>
+              </a:rPr>
               <a:t>Never guess names, dates, phone numbers, or locations.</a:t>
             </a:r>
           </a:p>
@@ -5666,13 +5725,14 @@
               <a:spcAft>
                 <a:spcPts val="400"/>
               </a:spcAft>
-              <a:defRPr sz="1300">
+            </a:pPr>
+            <a:r>
+              <a:rPr sz="1300" b="0">
                 <a:solidFill>
                   <a:srgbClr val="12211C"/>
                 </a:solidFill>
-              </a:defRPr>
-            </a:pPr>
-            <a:r>
+                <a:latin typeface="Aptos"/>
+              </a:rPr>
               <a:t>Keep private reporter details private.</a:t>
             </a:r>
           </a:p>
@@ -5681,13 +5741,14 @@
               <a:spcAft>
                 <a:spcPts val="400"/>
               </a:spcAft>
-              <a:defRPr sz="1300">
+            </a:pPr>
+            <a:r>
+              <a:rPr sz="1300" b="0">
                 <a:solidFill>
                   <a:srgbClr val="12211C"/>
                 </a:solidFill>
-              </a:defRPr>
-            </a:pPr>
-            <a:r>
+                <a:latin typeface="Aptos"/>
+              </a:rPr>
               <a:t>Do not publish without a source URL.</a:t>
             </a:r>
           </a:p>
@@ -5696,13 +5757,14 @@
               <a:spcAft>
                 <a:spcPts val="400"/>
               </a:spcAft>
-              <a:defRPr sz="1300">
+            </a:pPr>
+            <a:r>
+              <a:rPr sz="1300" b="0">
                 <a:solidFill>
                   <a:srgbClr val="12211C"/>
                 </a:solidFill>
-              </a:defRPr>
-            </a:pPr>
-            <a:r>
+                <a:latin typeface="Aptos"/>
+              </a:rPr>
               <a:t>Mark cases Found or Identified when resolved.</a:t>
             </a:r>
           </a:p>
@@ -5770,16 +5832,17 @@
           <a:noFill/>
         </p:spPr>
         <p:txBody>
-          <a:bodyPr wrap="none">
+          <a:bodyPr wrap="square">
             <a:spAutoFit/>
           </a:bodyPr>
           <a:lstStyle/>
           <a:p>
             <a:r>
-              <a:rPr b="1" sz="1600">
+              <a:rPr sz="1600" b="1">
                 <a:solidFill>
                   <a:srgbClr val="2F553B"/>
                 </a:solidFill>
+                <a:latin typeface="Mangal"/>
               </a:rPr>
               <a:t>??????</a:t>
             </a:r>
@@ -5789,13 +5852,14 @@
               <a:spcAft>
                 <a:spcPts val="400"/>
               </a:spcAft>
-              <a:defRPr sz="1300">
+            </a:pPr>
+            <a:r>
+              <a:rPr sz="1300" b="0">
                 <a:solidFill>
                   <a:srgbClr val="12211C"/>
                 </a:solidFill>
-              </a:defRPr>
-            </a:pPr>
-            <a:r>
+                <a:latin typeface="Mangal"/>
+              </a:rPr>
               <a:t>???, ????, ??? ?????, ?? ????? ?????? ???????????</a:t>
             </a:r>
           </a:p>
@@ -5804,13 +5868,14 @@
               <a:spcAft>
                 <a:spcPts val="400"/>
               </a:spcAft>
-              <a:defRPr sz="1300">
+            </a:pPr>
+            <a:r>
+              <a:rPr sz="1300" b="0">
                 <a:solidFill>
                   <a:srgbClr val="12211C"/>
                 </a:solidFill>
-              </a:defRPr>
-            </a:pPr>
-            <a:r>
+                <a:latin typeface="Mangal"/>
+              </a:rPr>
               <a:t>reporter ?? ???? ????? ????? ???????????</a:t>
             </a:r>
           </a:p>
@@ -5819,13 +5884,14 @@
               <a:spcAft>
                 <a:spcPts val="400"/>
               </a:spcAft>
-              <a:defRPr sz="1300">
+            </a:pPr>
+            <a:r>
+              <a:rPr sz="1300" b="0">
                 <a:solidFill>
                   <a:srgbClr val="12211C"/>
                 </a:solidFill>
-              </a:defRPr>
-            </a:pPr>
-            <a:r>
+                <a:latin typeface="Mangal"/>
+              </a:rPr>
               <a:t>????? URL ???? ??????? ???????? ???????????</a:t>
             </a:r>
           </a:p>
@@ -5834,13 +5900,14 @@
               <a:spcAft>
                 <a:spcPts val="400"/>
               </a:spcAft>
-              <a:defRPr sz="1300">
+            </a:pPr>
+            <a:r>
+              <a:rPr sz="1300" b="0">
                 <a:solidFill>
                   <a:srgbClr val="12211C"/>
                 </a:solidFill>
-              </a:defRPr>
-            </a:pPr>
-            <a:r>
+                <a:latin typeface="Mangal"/>
+              </a:rPr>
               <a:t>?????? ???? case ??? Found ?? Identified ???????????</a:t>
             </a:r>
           </a:p>
@@ -5981,19 +6048,19 @@
                 <a:solidFill>
                   <a:srgbClr val="12211C"/>
                 </a:solidFill>
+                <a:latin typeface="Aptos"/>
               </a:rPr>
               <a:t>Closing Notes</a:t>
             </a:r>
           </a:p>
           <a:p>
-            <a:pPr>
-              <a:defRPr sz="1200">
+            <a:r>
+              <a:rPr sz="1200" b="0">
                 <a:solidFill>
                   <a:srgbClr val="66706C"/>
                 </a:solidFill>
-              </a:defRPr>
-            </a:pPr>
-            <a:r>
+                <a:latin typeface="Aptos"/>
+              </a:rPr>
               <a:t>Handover checklist</a:t>
             </a:r>
           </a:p>
@@ -6061,16 +6128,17 @@
           <a:noFill/>
         </p:spPr>
         <p:txBody>
-          <a:bodyPr wrap="none">
+          <a:bodyPr wrap="square">
             <a:spAutoFit/>
           </a:bodyPr>
           <a:lstStyle/>
           <a:p>
             <a:r>
-              <a:rPr b="1" sz="1600">
+              <a:rPr sz="1600" b="1">
                 <a:solidFill>
                   <a:srgbClr val="2F553B"/>
                 </a:solidFill>
+                <a:latin typeface="Aptos"/>
               </a:rPr>
               <a:t>English</a:t>
             </a:r>
@@ -6080,13 +6148,14 @@
               <a:spcAft>
                 <a:spcPts val="400"/>
               </a:spcAft>
-              <a:defRPr sz="1300">
+            </a:pPr>
+            <a:r>
+              <a:rPr sz="1300" b="0">
                 <a:solidFill>
                   <a:srgbClr val="12211C"/>
                 </a:solidFill>
-              </a:defRPr>
-            </a:pPr>
-            <a:r>
+                <a:latin typeface="Aptos"/>
+              </a:rPr>
               <a:t>Review urgent items first.</a:t>
             </a:r>
           </a:p>
@@ -6095,13 +6164,14 @@
               <a:spcAft>
                 <a:spcPts val="400"/>
               </a:spcAft>
-              <a:defRPr sz="1300">
+            </a:pPr>
+            <a:r>
+              <a:rPr sz="1300" b="0">
                 <a:solidFill>
                   <a:srgbClr val="12211C"/>
                 </a:solidFill>
-              </a:defRPr>
-            </a:pPr>
-            <a:r>
+                <a:latin typeface="Aptos"/>
+              </a:rPr>
               <a:t>Export the event at shift end.</a:t>
             </a:r>
           </a:p>
@@ -6110,13 +6180,14 @@
               <a:spcAft>
                 <a:spcPts val="400"/>
               </a:spcAft>
-              <a:defRPr sz="1300">
+            </a:pPr>
+            <a:r>
+              <a:rPr sz="1300" b="0">
                 <a:solidFill>
                   <a:srgbClr val="12211C"/>
                 </a:solidFill>
-              </a:defRPr>
-            </a:pPr>
-            <a:r>
+                <a:latin typeface="Aptos"/>
+              </a:rPr>
               <a:t>Keep the help hub and PPTX handy for the next admin.</a:t>
             </a:r>
           </a:p>
@@ -6125,13 +6196,14 @@
               <a:spcAft>
                 <a:spcPts val="400"/>
               </a:spcAft>
-              <a:defRPr sz="1300">
+            </a:pPr>
+            <a:r>
+              <a:rPr sz="1300" b="0">
                 <a:solidFill>
                   <a:srgbClr val="12211C"/>
                 </a:solidFill>
-              </a:defRPr>
-            </a:pPr>
-            <a:r>
+                <a:latin typeface="Aptos"/>
+              </a:rPr>
               <a:t>When in doubt, preserve evidence and escalate to a human reviewer.</a:t>
             </a:r>
           </a:p>
@@ -6199,16 +6271,17 @@
           <a:noFill/>
         </p:spPr>
         <p:txBody>
-          <a:bodyPr wrap="none">
+          <a:bodyPr wrap="square">
             <a:spAutoFit/>
           </a:bodyPr>
           <a:lstStyle/>
           <a:p>
             <a:r>
-              <a:rPr b="1" sz="1600">
+              <a:rPr sz="1600" b="1">
                 <a:solidFill>
                   <a:srgbClr val="2F553B"/>
                 </a:solidFill>
+                <a:latin typeface="Mangal"/>
               </a:rPr>
               <a:t>??????</a:t>
             </a:r>
@@ -6218,13 +6291,14 @@
               <a:spcAft>
                 <a:spcPts val="400"/>
               </a:spcAft>
-              <a:defRPr sz="1300">
+            </a:pPr>
+            <a:r>
+              <a:rPr sz="1300" b="0">
                 <a:solidFill>
                   <a:srgbClr val="12211C"/>
                 </a:solidFill>
-              </a:defRPr>
-            </a:pPr>
-            <a:r>
+                <a:latin typeface="Mangal"/>
+              </a:rPr>
               <a:t>Urgent item ????? ??????? ??????????</a:t>
             </a:r>
           </a:p>
@@ -6233,13 +6307,14 @@
               <a:spcAft>
                 <a:spcPts val="400"/>
               </a:spcAft>
-              <a:defRPr sz="1300">
+            </a:pPr>
+            <a:r>
+              <a:rPr sz="1300" b="0">
                 <a:solidFill>
                   <a:srgbClr val="12211C"/>
                 </a:solidFill>
-              </a:defRPr>
-            </a:pPr>
-            <a:r>
+                <a:latin typeface="Mangal"/>
+              </a:rPr>
               <a:t>Shift ?????? event export ??????????</a:t>
             </a:r>
           </a:p>
@@ -6248,13 +6323,14 @@
               <a:spcAft>
                 <a:spcPts val="400"/>
               </a:spcAft>
-              <a:defRPr sz="1300">
+            </a:pPr>
+            <a:r>
+              <a:rPr sz="1300" b="0">
                 <a:solidFill>
                   <a:srgbClr val="12211C"/>
                 </a:solidFill>
-              </a:defRPr>
-            </a:pPr>
-            <a:r>
+                <a:latin typeface="Mangal"/>
+              </a:rPr>
               <a:t>????? admin ?? ???? help hub ? PPTX ?????? ???????????</a:t>
             </a:r>
           </a:p>
@@ -6263,13 +6339,14 @@
               <a:spcAft>
                 <a:spcPts val="400"/>
               </a:spcAft>
-              <a:defRPr sz="1300">
+            </a:pPr>
+            <a:r>
+              <a:rPr sz="1300" b="0">
                 <a:solidFill>
                   <a:srgbClr val="12211C"/>
                 </a:solidFill>
-              </a:defRPr>
-            </a:pPr>
-            <a:r>
+                <a:latin typeface="Mangal"/>
+              </a:rPr>
               <a:t>?????? ???? ?????? ???????? ????? ???? ??????? ??????????</a:t>
             </a:r>
           </a:p>

</xml_diff>